<commit_message>
Besluit 96 aangepast: clubbeheerder (van de club) en ClubComm-adviseur (van ons)
Co-Authored-By: Claude Opus 5.5 <noreply@anthropic.com>
Claude-Session: https://claude.ai/code/session_01JemqRo5kiX7AhhtzuggotQ
</commit_message>
<xml_diff>
--- a/docs/presentaties/ClubComm-productoverzicht.pptx
+++ b/docs/presentaties/ClubComm-productoverzicht.pptx
@@ -2597,7 +2597,7 @@
                 <a:ea typeface="Calibri" pitchFamily="34" charset="-122"/>
                 <a:cs typeface="Calibri" pitchFamily="34" charset="-120"/>
               </a:rPr>
-              <a:t>CLUBMANAGER</a:t>
+              <a:t>CLUBBEHEERDER</a:t>
             </a:r>
             <a:endParaRPr lang="en-US" sz="1300" dirty="0"/>
           </a:p>
@@ -2677,7 +2677,7 @@
                 <a:ea typeface="Calibri" pitchFamily="34" charset="-122"/>
                 <a:cs typeface="Calibri" pitchFamily="34" charset="-120"/>
               </a:rPr>
-              <a:t>Voorzitter, coördinator of verenigingsmanager. Aanspreekpunt voor de ClubComm-manager.</a:t>
+              <a:t>Voorzitter, coördinator of verenigingsmanager. Aanspreekpunt voor de ClubComm-adviseur.</a:t>
             </a:r>
             <a:endParaRPr lang="en-US" sz="1600" dirty="0"/>
           </a:p>
@@ -7810,7 +7810,7 @@
                 <a:ea typeface="Calibri" pitchFamily="34" charset="-122"/>
                 <a:cs typeface="Calibri" pitchFamily="34" charset="-120"/>
               </a:rPr>
-              <a:t>De ClubComm-manager beheert clubs; één account bij meerdere clubs.</a:t>
+              <a:t>De ClubComm-adviseur beheert clubs; één account bij meerdere clubs.</a:t>
             </a:r>
             <a:endParaRPr lang="en-US" sz="1700" dirty="0"/>
           </a:p>
@@ -8193,7 +8193,7 @@
                 <a:ea typeface="Calibri" pitchFamily="34" charset="-122"/>
                 <a:cs typeface="Calibri" pitchFamily="34" charset="-120"/>
               </a:rPr>
-              <a:t>Vragen of aanpassen: bel de ClubComm-manager</a:t>
+              <a:t>Vragen of aanpassen: bel de ClubComm-adviseur</a:t>
             </a:r>
             <a:endParaRPr lang="en-US" sz="1800" dirty="0"/>
           </a:p>
@@ -9022,7 +9022,7 @@
                 <a:ea typeface="Calibri" pitchFamily="34" charset="-122"/>
                 <a:cs typeface="Calibri" pitchFamily="34" charset="-120"/>
               </a:rPr>
-              <a:t>ClubComm-manager  ↔  Clubmanager</a:t>
+              <a:t>ClubComm-adviseur  ↔  Clubbeheerder</a:t>
             </a:r>
             <a:endParaRPr lang="en-US" sz="1500" dirty="0"/>
           </a:p>
@@ -10024,7 +10024,7 @@
                 <a:ea typeface="Calibri" pitchFamily="34" charset="-122"/>
                 <a:cs typeface="Calibri" pitchFamily="34" charset="-120"/>
               </a:rPr>
-              <a:t>Geen coördinator? Dan doet de HO het. Geen HO? Dan wijst de clubmanager iemand aan. Er valt nooit iets tussen wal en schip.</a:t>
+              <a:t>Geen coördinator? Dan doet de HO het. Geen HO? Dan wijst de clubbeheerder iemand aan. Er valt nooit iets tussen wal en schip.</a:t>
             </a:r>
             <a:endParaRPr lang="en-US" sz="1700" dirty="0"/>
           </a:p>
@@ -10146,7 +10146,7 @@
                 <a:ea typeface="Calibri" pitchFamily="34" charset="-122"/>
                 <a:cs typeface="Calibri" pitchFamily="34" charset="-120"/>
               </a:rPr>
-              <a:t>Elke taak kan bij een andere rol. Wij leveren een standaard; de clubmanager past hem aan.</a:t>
+              <a:t>Elke taak kan bij een andere rol. Wij leveren een standaard; de clubbeheerder past hem aan.</a:t>
             </a:r>
             <a:endParaRPr lang="en-US" sz="1700" dirty="0"/>
           </a:p>

</xml_diff>